<commit_message>
small changes in chunk 8
</commit_message>
<xml_diff>
--- a/Lecture Resources/Lecture Powerpoints/Chunk 8  - 1D Numpy.pptx
+++ b/Lecture Resources/Lecture Powerpoints/Chunk 8  - 1D Numpy.pptx
@@ -759,7 +759,7 @@
           <a:p>
             <a:fld id="{0B6CA2EE-5589-4682-AD7F-744DBF1E81F5}" type="datetimeFigureOut">
               <a:rPr lang="de-DE" smtClean="0"/>
-              <a:t>08.10.2025</a:t>
+              <a:t>09.10.2025</a:t>
             </a:fld>
             <a:endParaRPr lang="de-DE"/>
           </a:p>
@@ -1026,6 +1026,90 @@
 </p:notesMaster>
 </file>
 
+<file path=ppt/notesSlides/notesSlide1.xml><?xml version="1.0" encoding="utf-8"?>
+<p:notes xmlns:a="http://schemas.openxmlformats.org/drawingml/2006/main" xmlns:r="http://schemas.openxmlformats.org/officeDocument/2006/relationships" xmlns:p="http://schemas.openxmlformats.org/presentationml/2006/main">
+  <p:cSld>
+    <p:spTree>
+      <p:nvGrpSpPr>
+        <p:cNvPr id="1" name=""/>
+        <p:cNvGrpSpPr/>
+        <p:nvPr/>
+      </p:nvGrpSpPr>
+      <p:grpSpPr>
+        <a:xfrm>
+          <a:off x="0" y="0"/>
+          <a:ext cx="0" cy="0"/>
+          <a:chOff x="0" y="0"/>
+          <a:chExt cx="0" cy="0"/>
+        </a:xfrm>
+      </p:grpSpPr>
+      <p:sp>
+        <p:nvSpPr>
+          <p:cNvPr id="2" name="Slide Image Placeholder 1"/>
+          <p:cNvSpPr>
+            <a:spLocks noGrp="1" noRot="1" noChangeAspect="1"/>
+          </p:cNvSpPr>
+          <p:nvPr>
+            <p:ph type="sldImg"/>
+          </p:nvPr>
+        </p:nvSpPr>
+        <p:spPr/>
+      </p:sp>
+      <p:sp>
+        <p:nvSpPr>
+          <p:cNvPr id="3" name="Notes Placeholder 2"/>
+          <p:cNvSpPr>
+            <a:spLocks noGrp="1"/>
+          </p:cNvSpPr>
+          <p:nvPr>
+            <p:ph type="body" idx="1"/>
+          </p:nvPr>
+        </p:nvSpPr>
+        <p:spPr/>
+        <p:txBody>
+          <a:bodyPr/>
+          <a:lstStyle/>
+          <a:p>
+            <a:endParaRPr lang="de-DE" dirty="0"/>
+          </a:p>
+        </p:txBody>
+      </p:sp>
+      <p:sp>
+        <p:nvSpPr>
+          <p:cNvPr id="4" name="Slide Number Placeholder 3"/>
+          <p:cNvSpPr>
+            <a:spLocks noGrp="1"/>
+          </p:cNvSpPr>
+          <p:nvPr>
+            <p:ph type="sldNum" sz="quarter" idx="5"/>
+          </p:nvPr>
+        </p:nvSpPr>
+        <p:spPr/>
+        <p:txBody>
+          <a:bodyPr/>
+          <a:lstStyle/>
+          <a:p>
+            <a:fld id="{11422C3B-6429-4381-8F08-B422F3CD22BF}" type="slidenum">
+              <a:rPr lang="de-DE" smtClean="0"/>
+              <a:t>2</a:t>
+            </a:fld>
+            <a:endParaRPr lang="de-DE"/>
+          </a:p>
+        </p:txBody>
+      </p:sp>
+    </p:spTree>
+    <p:extLst>
+      <p:ext uri="{BB962C8B-B14F-4D97-AF65-F5344CB8AC3E}">
+        <p14:creationId xmlns:p14="http://schemas.microsoft.com/office/powerpoint/2010/main" val="2959918295"/>
+      </p:ext>
+    </p:extLst>
+  </p:cSld>
+  <p:clrMapOvr>
+    <a:masterClrMapping/>
+  </p:clrMapOvr>
+</p:notes>
+</file>
+
 <file path=ppt/slideLayouts/slideLayout1.xml><?xml version="1.0" encoding="utf-8"?>
 <p:sldLayout xmlns:a="http://schemas.openxmlformats.org/drawingml/2006/main" xmlns:r="http://schemas.openxmlformats.org/officeDocument/2006/relationships" xmlns:p="http://schemas.openxmlformats.org/presentationml/2006/main" type="title" preserve="1">
   <p:cSld name="Titelfolie">
@@ -1173,7 +1257,7 @@
           <a:p>
             <a:fld id="{ADA51F25-4808-47F4-BF6E-BCDC230DB01C}" type="datetimeFigureOut">
               <a:rPr lang="de-DE" smtClean="0"/>
-              <a:t>08.10.2025</a:t>
+              <a:t>09.10.2025</a:t>
             </a:fld>
             <a:endParaRPr lang="de-DE"/>
           </a:p>
@@ -1371,7 +1455,7 @@
           <a:p>
             <a:fld id="{ADA51F25-4808-47F4-BF6E-BCDC230DB01C}" type="datetimeFigureOut">
               <a:rPr lang="de-DE" smtClean="0"/>
-              <a:t>08.10.2025</a:t>
+              <a:t>09.10.2025</a:t>
             </a:fld>
             <a:endParaRPr lang="de-DE"/>
           </a:p>
@@ -1579,7 +1663,7 @@
           <a:p>
             <a:fld id="{ADA51F25-4808-47F4-BF6E-BCDC230DB01C}" type="datetimeFigureOut">
               <a:rPr lang="de-DE" smtClean="0"/>
-              <a:t>08.10.2025</a:t>
+              <a:t>09.10.2025</a:t>
             </a:fld>
             <a:endParaRPr lang="de-DE"/>
           </a:p>
@@ -1777,7 +1861,7 @@
           <a:p>
             <a:fld id="{ADA51F25-4808-47F4-BF6E-BCDC230DB01C}" type="datetimeFigureOut">
               <a:rPr lang="de-DE" smtClean="0"/>
-              <a:t>08.10.2025</a:t>
+              <a:t>09.10.2025</a:t>
             </a:fld>
             <a:endParaRPr lang="de-DE"/>
           </a:p>
@@ -2052,7 +2136,7 @@
           <a:p>
             <a:fld id="{ADA51F25-4808-47F4-BF6E-BCDC230DB01C}" type="datetimeFigureOut">
               <a:rPr lang="de-DE" smtClean="0"/>
-              <a:t>08.10.2025</a:t>
+              <a:t>09.10.2025</a:t>
             </a:fld>
             <a:endParaRPr lang="de-DE"/>
           </a:p>
@@ -2317,7 +2401,7 @@
           <a:p>
             <a:fld id="{ADA51F25-4808-47F4-BF6E-BCDC230DB01C}" type="datetimeFigureOut">
               <a:rPr lang="de-DE" smtClean="0"/>
-              <a:t>08.10.2025</a:t>
+              <a:t>09.10.2025</a:t>
             </a:fld>
             <a:endParaRPr lang="de-DE"/>
           </a:p>
@@ -2729,7 +2813,7 @@
           <a:p>
             <a:fld id="{ADA51F25-4808-47F4-BF6E-BCDC230DB01C}" type="datetimeFigureOut">
               <a:rPr lang="de-DE" smtClean="0"/>
-              <a:t>08.10.2025</a:t>
+              <a:t>09.10.2025</a:t>
             </a:fld>
             <a:endParaRPr lang="de-DE"/>
           </a:p>
@@ -2870,7 +2954,7 @@
           <a:p>
             <a:fld id="{ADA51F25-4808-47F4-BF6E-BCDC230DB01C}" type="datetimeFigureOut">
               <a:rPr lang="de-DE" smtClean="0"/>
-              <a:t>08.10.2025</a:t>
+              <a:t>09.10.2025</a:t>
             </a:fld>
             <a:endParaRPr lang="de-DE"/>
           </a:p>
@@ -2983,7 +3067,7 @@
           <a:p>
             <a:fld id="{ADA51F25-4808-47F4-BF6E-BCDC230DB01C}" type="datetimeFigureOut">
               <a:rPr lang="de-DE" smtClean="0"/>
-              <a:t>08.10.2025</a:t>
+              <a:t>09.10.2025</a:t>
             </a:fld>
             <a:endParaRPr lang="de-DE"/>
           </a:p>
@@ -3294,7 +3378,7 @@
           <a:p>
             <a:fld id="{ADA51F25-4808-47F4-BF6E-BCDC230DB01C}" type="datetimeFigureOut">
               <a:rPr lang="de-DE" smtClean="0"/>
-              <a:t>08.10.2025</a:t>
+              <a:t>09.10.2025</a:t>
             </a:fld>
             <a:endParaRPr lang="de-DE"/>
           </a:p>
@@ -3582,7 +3666,7 @@
           <a:p>
             <a:fld id="{ADA51F25-4808-47F4-BF6E-BCDC230DB01C}" type="datetimeFigureOut">
               <a:rPr lang="de-DE" smtClean="0"/>
-              <a:t>08.10.2025</a:t>
+              <a:t>09.10.2025</a:t>
             </a:fld>
             <a:endParaRPr lang="de-DE"/>
           </a:p>
@@ -3823,7 +3907,7 @@
           <a:p>
             <a:fld id="{ADA51F25-4808-47F4-BF6E-BCDC230DB01C}" type="datetimeFigureOut">
               <a:rPr lang="de-DE" smtClean="0"/>
-              <a:t>08.10.2025</a:t>
+              <a:t>09.10.2025</a:t>
             </a:fld>
             <a:endParaRPr lang="de-DE"/>
           </a:p>
@@ -4453,66 +4537,68 @@
           <a:p>
             <a:r>
               <a:rPr lang="en-US" dirty="0"/>
-              <a:t>Problem: loops and lists are “slow”: </a:t>
-            </a:r>
-            <a:br>
-              <a:rPr lang="en-US" dirty="0"/>
-            </a:br>
+              <a:t>Problem: loops and lists are “slow”:</a:t>
+            </a:r>
+          </a:p>
+          <a:p>
+            <a:pPr lvl="1">
+              <a:buFont typeface="Aptos" panose="020B0004020202020204" pitchFamily="34" charset="0"/>
+              <a:buChar char="→"/>
+            </a:pPr>
             <a:r>
               <a:rPr lang="en-US" dirty="0">
                 <a:sym typeface="Wingdings" panose="05000000000000000000" pitchFamily="2" charset="2"/>
               </a:rPr>
-              <a:t> Example: square 100 000 000 numbers and sum them</a:t>
-            </a:r>
-            <a:br>
+              <a:t>Example: square 100 000 000 numbers and sum them</a:t>
+            </a:r>
+          </a:p>
+          <a:p>
+            <a:pPr lvl="1">
+              <a:buFont typeface="Aptos" panose="020B0004020202020204" pitchFamily="34" charset="0"/>
+              <a:buChar char="→"/>
+            </a:pPr>
+            <a:r>
               <a:rPr lang="en-US" dirty="0">
                 <a:sym typeface="Wingdings" panose="05000000000000000000" pitchFamily="2" charset="2"/>
               </a:rPr>
-            </a:br>
+              <a:t>28 seconds </a:t>
+            </a:r>
+            <a:endParaRPr lang="en-US" dirty="0"/>
+          </a:p>
+          <a:p>
+            <a:endParaRPr lang="en-US" dirty="0"/>
+          </a:p>
+          <a:p>
+            <a:r>
+              <a:rPr lang="en-US" dirty="0"/>
+              <a:t>Solution: Using C-code in python</a:t>
+            </a:r>
+          </a:p>
+          <a:p>
+            <a:pPr lvl="1">
+              <a:buFont typeface="Aptos" panose="020B0004020202020204" pitchFamily="34" charset="0"/>
+              <a:buChar char="→"/>
+            </a:pPr>
             <a:r>
               <a:rPr lang="en-US" dirty="0">
                 <a:sym typeface="Wingdings" panose="05000000000000000000" pitchFamily="2" charset="2"/>
               </a:rPr>
-              <a:t> 28 seconds </a:t>
-            </a:r>
-            <a:endParaRPr lang="en-US" dirty="0"/>
-          </a:p>
-          <a:p>
-            <a:endParaRPr lang="en-US" dirty="0"/>
-          </a:p>
-          <a:p>
-            <a:r>
-              <a:rPr lang="en-US" dirty="0"/>
-              <a:t>Solution: Using C-code in python</a:t>
-            </a:r>
-            <a:br>
-              <a:rPr lang="en-US" dirty="0"/>
-            </a:br>
-            <a:r>
-              <a:rPr lang="en-US" dirty="0">
-                <a:sym typeface="Wingdings" panose="05000000000000000000" pitchFamily="2" charset="2"/>
-              </a:rPr>
-              <a:t> 0.5 seconds</a:t>
-            </a:r>
-            <a:br>
-              <a:rPr lang="en-US" dirty="0">
-                <a:sym typeface="Wingdings" panose="05000000000000000000" pitchFamily="2" charset="2"/>
-              </a:rPr>
-            </a:br>
-            <a:r>
-              <a:rPr lang="en-US" dirty="0">
-                <a:sym typeface="Wingdings" panose="05000000000000000000" pitchFamily="2" charset="2"/>
-              </a:rPr>
-              <a:t> </a:t>
-            </a:r>
-            <a:r>
-              <a:rPr lang="en-US" dirty="0" err="1">
+              <a:t>0.5 seconds</a:t>
+            </a:r>
+          </a:p>
+          <a:p>
+            <a:pPr lvl="1">
+              <a:buFont typeface="Aptos" panose="020B0004020202020204" pitchFamily="34" charset="0"/>
+              <a:buChar char="→"/>
+            </a:pPr>
+            <a:r>
+              <a:rPr lang="en-US" b="1" dirty="0" err="1">
                 <a:sym typeface="Wingdings" panose="05000000000000000000" pitchFamily="2" charset="2"/>
               </a:rPr>
               <a:t>Numpy</a:t>
             </a:r>
             <a:r>
-              <a:rPr lang="en-US" dirty="0">
+              <a:rPr lang="en-US" b="1" dirty="0">
                 <a:sym typeface="Wingdings" panose="05000000000000000000" pitchFamily="2" charset="2"/>
               </a:rPr>
               <a:t> is typically 10 – 100 x faster</a:t>
@@ -4552,7 +4638,7 @@
           <p:nvPr/>
         </p:nvPicPr>
         <p:blipFill>
-          <a:blip r:embed="rId2"/>
+          <a:blip r:embed="rId3"/>
           <a:stretch>
             <a:fillRect/>
           </a:stretch>
@@ -4592,7 +4678,7 @@
           <p:nvPr/>
         </p:nvPicPr>
         <p:blipFill>
-          <a:blip r:embed="rId3"/>
+          <a:blip r:embed="rId4"/>
           <a:stretch>
             <a:fillRect/>
           </a:stretch>
@@ -4771,7 +4857,7 @@
                                         <p:tgtEl>
                                           <p:spTgt spid="3">
                                             <p:txEl>
-                                              <p:pRg st="2" end="2"/>
+                                              <p:pRg st="4" end="4"/>
                                             </p:txEl>
                                           </p:spTgt>
                                         </p:tgtEl>
@@ -4787,7 +4873,7 @@
                                 </p:cTn>
                               </p:par>
                               <p:par>
-                                <p:cTn id="7" presetID="1" presetClass="entr" presetSubtype="0" fill="hold" nodeType="withEffect">
+                                <p:cTn id="7" presetID="1" presetClass="entr" presetSubtype="0" fill="hold" grpId="0" nodeType="withEffect">
                                   <p:stCondLst>
                                     <p:cond delay="0"/>
                                   </p:stCondLst>
@@ -4795,6 +4881,33 @@
                                     <p:set>
                                       <p:cBhvr>
                                         <p:cTn id="8" dur="1" fill="hold">
+                                          <p:stCondLst>
+                                            <p:cond delay="0"/>
+                                          </p:stCondLst>
+                                        </p:cTn>
+                                        <p:tgtEl>
+                                          <p:spTgt spid="9"/>
+                                        </p:tgtEl>
+                                        <p:attrNameLst>
+                                          <p:attrName>style.visibility</p:attrName>
+                                        </p:attrNameLst>
+                                      </p:cBhvr>
+                                      <p:to>
+                                        <p:strVal val="visible"/>
+                                      </p:to>
+                                    </p:set>
+                                  </p:childTnLst>
+                                </p:cTn>
+                              </p:par>
+                              <p:par>
+                                <p:cTn id="9" presetID="1" presetClass="entr" presetSubtype="0" fill="hold" nodeType="withEffect">
+                                  <p:stCondLst>
+                                    <p:cond delay="0"/>
+                                  </p:stCondLst>
+                                  <p:childTnLst>
+                                    <p:set>
+                                      <p:cBhvr>
+                                        <p:cTn id="10" dur="1" fill="hold">
                                           <p:stCondLst>
                                             <p:cond delay="0"/>
                                           </p:stCondLst>
@@ -4814,20 +4927,55 @@
                                 </p:cTn>
                               </p:par>
                               <p:par>
-                                <p:cTn id="9" presetID="1" presetClass="entr" presetSubtype="0" fill="hold" grpId="0" nodeType="withEffect">
+                                <p:cTn id="11" presetID="1" presetClass="entr" presetSubtype="0" fill="hold" nodeType="withEffect">
                                   <p:stCondLst>
                                     <p:cond delay="0"/>
                                   </p:stCondLst>
                                   <p:childTnLst>
                                     <p:set>
                                       <p:cBhvr>
-                                        <p:cTn id="10" dur="1" fill="hold">
+                                        <p:cTn id="12" dur="1" fill="hold">
                                           <p:stCondLst>
                                             <p:cond delay="0"/>
                                           </p:stCondLst>
                                         </p:cTn>
                                         <p:tgtEl>
-                                          <p:spTgt spid="9"/>
+                                          <p:spTgt spid="3">
+                                            <p:txEl>
+                                              <p:pRg st="5" end="5"/>
+                                            </p:txEl>
+                                          </p:spTgt>
+                                        </p:tgtEl>
+                                        <p:attrNameLst>
+                                          <p:attrName>style.visibility</p:attrName>
+                                        </p:attrNameLst>
+                                      </p:cBhvr>
+                                      <p:to>
+                                        <p:strVal val="visible"/>
+                                      </p:to>
+                                    </p:set>
+                                  </p:childTnLst>
+                                </p:cTn>
+                              </p:par>
+                              <p:par>
+                                <p:cTn id="13" presetID="1" presetClass="entr" presetSubtype="0" fill="hold" nodeType="withEffect">
+                                  <p:stCondLst>
+                                    <p:cond delay="0"/>
+                                  </p:stCondLst>
+                                  <p:childTnLst>
+                                    <p:set>
+                                      <p:cBhvr>
+                                        <p:cTn id="14" dur="1" fill="hold">
+                                          <p:stCondLst>
+                                            <p:cond delay="0"/>
+                                          </p:stCondLst>
+                                        </p:cTn>
+                                        <p:tgtEl>
+                                          <p:spTgt spid="3">
+                                            <p:txEl>
+                                              <p:pRg st="6" end="6"/>
+                                            </p:txEl>
+                                          </p:spTgt>
                                         </p:tgtEl>
                                         <p:attrNameLst>
                                           <p:attrName>style.visibility</p:attrName>
@@ -4847,26 +4995,26 @@
                     </p:cTn>
                   </p:par>
                   <p:par>
-                    <p:cTn id="11" fill="hold">
+                    <p:cTn id="15" fill="hold">
                       <p:stCondLst>
                         <p:cond delay="indefinite"/>
                       </p:stCondLst>
                       <p:childTnLst>
                         <p:par>
-                          <p:cTn id="12" fill="hold">
+                          <p:cTn id="16" fill="hold">
                             <p:stCondLst>
                               <p:cond delay="0"/>
                             </p:stCondLst>
                             <p:childTnLst>
                               <p:par>
-                                <p:cTn id="13" presetID="1" presetClass="entr" presetSubtype="0" fill="hold" nodeType="clickEffect">
+                                <p:cTn id="17" presetID="1" presetClass="entr" presetSubtype="0" fill="hold" nodeType="clickEffect">
                                   <p:stCondLst>
                                     <p:cond delay="0"/>
                                   </p:stCondLst>
                                   <p:childTnLst>
                                     <p:set>
                                       <p:cBhvr>
-                                        <p:cTn id="14" dur="1" fill="hold">
+                                        <p:cTn id="18" dur="1" fill="hold">
                                           <p:stCondLst>
                                             <p:cond delay="0"/>
                                           </p:stCondLst>
@@ -4874,7 +5022,7 @@
                                         <p:tgtEl>
                                           <p:spTgt spid="3">
                                             <p:txEl>
-                                              <p:pRg st="4" end="4"/>
+                                              <p:pRg st="8" end="8"/>
                                             </p:txEl>
                                           </p:spTgt>
                                         </p:tgtEl>

</xml_diff>